<commit_message>
Week 3: add demo data + Claude Code example, update L5 deck
- Add reviews.csv fallback (1,066 balanced rows) for the demo's offline path
- Add claude_code_example/ scaffold (train/predict/test/requirements/README)
- Update L5 deck: fix slide 5 TF-IDF worked example, reword slide 11 gotcha

Co-Authored-By: Claude Opus 4.8 <noreply@anthropic.com>
</commit_message>
<xml_diff>
--- a/Week 3/L5_Supervised_Text_Classification.pptx
+++ b/Week 3/L5_Supervised_Text_Classification.pptx
@@ -2965,7 +2965,7 @@
                 <a:ea typeface="Calibri" pitchFamily="34" charset="-122"/>
                 <a:cs typeface="Calibri" pitchFamily="34" charset="-120"/>
               </a:rPr>
-              <a:t>Gemini’s first draft evaluated on the training set and reported 99%. It looked perfect and shipped. Who is accountable for the bug — the tool, the person who prompted, or the person who reviewed? How would a teammate even catch it?</a:t>
+              <a:t>Gemini’s first draft evaluated on the training set and reported a near-perfect score. It looked perfect and shipped. Who is accountable for the bug — the tool, the person who prompted, or the person who reviewed? How would a teammate even catch it?</a:t>
             </a:r>
             <a:endParaRPr lang="en-US" sz="1400" dirty="0"/>
           </a:p>
@@ -7530,7 +7530,7 @@
                 <a:ea typeface="Consolas" pitchFamily="34" charset="-122"/>
                 <a:cs typeface="Consolas" pitchFamily="34" charset="-120"/>
               </a:rPr>
-              <a:t>  d3  “funny and sharp, not dull”   → pos</a:t>
+              <a:t>  d3  “a funny, sharp film, not dull” → pos</a:t>
             </a:r>
             <a:endParaRPr lang="en-US" sz="1150" dirty="0"/>
           </a:p>
@@ -7599,7 +7599,7 @@
                 <a:ea typeface="Consolas" pitchFamily="34" charset="-122"/>
                 <a:cs typeface="Consolas" pitchFamily="34" charset="-120"/>
               </a:rPr>
-              <a:t>   d1     0.71   0.00   0.00   0.41</a:t>
+              <a:t>   d1     0.79   0.00   0.00   0.61</a:t>
             </a:r>
             <a:endParaRPr lang="en-US" sz="1150" dirty="0"/>
           </a:p>
@@ -7619,7 +7619,7 @@
                 <a:ea typeface="Consolas" pitchFamily="34" charset="-122"/>
                 <a:cs typeface="Consolas" pitchFamily="34" charset="-120"/>
               </a:rPr>
-              <a:t>   d2     0.00   0.58   0.58   0.41</a:t>
+              <a:t>   d2     0.00   0.62   0.62   0.48</a:t>
             </a:r>
             <a:endParaRPr lang="en-US" sz="1150" dirty="0"/>
           </a:p>
@@ -7639,7 +7639,7 @@
                 <a:ea typeface="Consolas" pitchFamily="34" charset="-122"/>
                 <a:cs typeface="Consolas" pitchFamily="34" charset="-120"/>
               </a:rPr>
-              <a:t>   d3     0.50   0.50   0.50   0.00</a:t>
+              <a:t>   d3     0.53   0.53   0.53   0.41</a:t>
             </a:r>
             <a:endParaRPr lang="en-US" sz="1150" dirty="0"/>
           </a:p>

</xml_diff>